<commit_message>
build: dung lai slide sau khi keo ve ban sua noi dung
Commit 2a93063 sua ca hai bo slide (10-slides.md 95 dong, 12-slides-mon-hoc.md
24 dong) nhung PPTX chua dung lai, nen ban trong nop/ da lac hau.

Da kiem truoc khi dung: khong con so cu nao bi dua tro lai (A4 0,9454, A6
0,7512, 2 dong 0,6996, dong gop 11,39, chenh 25,45, A7 0,5552, P2 2,379, test
1.001 -- deu sach), va so moi co du o ca hai bo. Rieng '319' trong slide mon
hoc la do tre sieu phan giai (+319 ms p95), khong phai so bien sua -- bao nham
cua mau quet.

Cong kiem theo AGENTS.md muc 7:
  530 test AI passed  (con so trong AGENTS.md dung chinh xac -- da kiem)
  1002 test toan bo passed
  ban tot nghiep: 107 tham chieu + 11 anh, 0 chet
  ban mon hoc   : 68 tham chieu + 9 anh, 0 chet
  38 slide 0 loi
  .env khong nam trong git

Co-Authored-By: Claude Opus 5 <noreply@anthropic.com>
</commit_message>
<xml_diff>
--- a/docs/slides/12-slides-mon-hoc.pptx
+++ b/docs/slides/12-slides-mon-hoc.pptx
@@ -43963,7 +43963,7 @@
   <p:cSld>
     <p:spTree>
       <p:nvGrpSpPr>
-        <p:cNvPr id="134" name="Shape 134"/>
+        <p:cNvPr id="428" name="Shape 428"/>
         <p:cNvGrpSpPr/>
         <p:nvPr/>
       </p:nvGrpSpPr>
@@ -43977,7 +43977,7 @@
       </p:grpSpPr>
       <p:sp>
         <p:nvSpPr>
-          <p:cNvPr id="142" name="Google Shape;142;p23"/>
+          <p:cNvPr id="436" name="Google Shape;436;p31"/>
           <p:cNvSpPr txBox="1"/>
           <p:nvPr>
             <p:ph type="title"/>
@@ -43985,8 +43985,8 @@
         </p:nvSpPr>
         <p:spPr>
           <a:xfrm>
-            <a:off x="774145" y="223964"/>
-            <a:ext cx="10579655" cy="785896"/>
+            <a:off x="771525" y="200025"/>
+            <a:ext cx="10582275" cy="790575"/>
           </a:xfrm>
           <a:prstGeom prst="rect">
             <a:avLst/>
@@ -44012,10 +44012,10 @@
       </p:sp>
       <p:sp>
         <p:nvSpPr>
-          <p:cNvPr id="143" name="Google Shape;143;p23"/>
+          <p:cNvPr id="437" name="Google Shape;437;p31"/>
           <p:cNvSpPr txBox="1"/>
           <p:nvPr>
-            <p:ph idx="1"/>
+            <p:ph idx="2" sz="half" type="body"/>
           </p:nvPr>
         </p:nvSpPr>
         <p:spPr/>
@@ -44031,20 +44031,41 @@
               <a:t>Đo mức ký tự thì hai bố cục gần bằng nhau; đo cả chuỗi thì cách một trời một vực.</a:t>
             </a:r>
           </a:p>
-          <a:p>
-            <a:pPr lvl="0" indent="0" marL="0">
-              <a:buNone/>
-            </a:pPr>
-            <a:r>
-              <a:rPr/>
-              <a:t>![](figures/fig-ch4-bố cục.png)</a:t>
-            </a:r>
-          </a:p>
         </p:txBody>
       </p:sp>
+      <p:pic>
+        <p:nvPicPr>
+          <p:cNvPr descr="figures/fig-ch4-layout.png" id="0" name="Picture 1"/>
+          <p:cNvPicPr>
+            <a:picLocks noGrp="1" noChangeAspect="1"/>
+          </p:cNvPicPr>
+          <p:nvPr/>
+        </p:nvPicPr>
+        <p:blipFill>
+          <a:blip r:embed="rId2"/>
+          <a:stretch>
+            <a:fillRect/>
+          </a:stretch>
+        </p:blipFill>
+        <p:spPr bwMode="auto">
+          <a:xfrm>
+            <a:off x="2489200" y="2324100"/>
+            <a:ext cx="7112000" cy="3848100"/>
+          </a:xfrm>
+          <a:prstGeom prst="rect">
+            <a:avLst/>
+          </a:prstGeom>
+          <a:noFill/>
+          <a:ln w="9525">
+            <a:noFill/>
+            <a:headEnd/>
+            <a:tailEnd/>
+          </a:ln>
+        </p:spPr>
+      </p:pic>
       <p:sp>
         <p:nvSpPr>
-          <p:cNvPr id="155" name="Google Shape;155;p23"/>
+          <p:cNvPr id="449" name="Google Shape;449;p31"/>
           <p:cNvSpPr txBox="1"/>
           <p:nvPr>
             <p:ph idx="12" type="sldNum"/>
@@ -44297,7 +44318,7 @@
             </a:pPr>
             <a:r>
               <a:rPr/>
-              <a:t>Ba ca hậu xử lý cứu được, ba ca vẫn sai — </a:t>
+              <a:t>Ba ca được chuẩn hóa đúng nhờ hậu xử lý, ba ca vẫn sai — </a:t>
             </a:r>
             <a:r>
               <a:rPr b="1"/>
@@ -44655,12 +44676,12 @@
                     <a:bodyPr/>
                     <a:lstStyle/>
                     <a:p>
-                      <a:pPr lvl="0" indent="0" marL="0" algn="r">
+                      <a:pPr lvl="0" indent="0" marL="0">
                         <a:buNone/>
                       </a:pPr>
                       <a:r>
                         <a:rPr/>
-                        <a:t>cải thiện được</a:t>
+                        <a:t>Cải thiện được</a:t>
                       </a:r>
                     </a:p>
                   </a:txBody>
@@ -44676,7 +44697,7 @@
                       </a:pPr>
                       <a:r>
                         <a:rPr/>
-                        <a:t>Giá phải trả</a:t>
+                        <a:t>Chi phí tính toán</a:t>
                       </a:r>
                     </a:p>
                   </a:txBody>
@@ -44704,7 +44725,7 @@
                     <a:bodyPr/>
                     <a:lstStyle/>
                     <a:p>
-                      <a:pPr lvl="0" indent="0" marL="0" algn="r">
+                      <a:pPr lvl="0" indent="0" marL="0">
                         <a:buNone/>
                       </a:pPr>
                       <a:r>
@@ -44751,7 +44772,7 @@
                     <a:bodyPr/>
                     <a:lstStyle/>
                     <a:p>
-                      <a:pPr lvl="0" indent="0" marL="0" algn="r">
+                      <a:pPr lvl="0" indent="0" marL="0">
                         <a:buNone/>
                       </a:pPr>
                       <a:r>
@@ -44806,7 +44827,7 @@
                     <a:bodyPr/>
                     <a:lstStyle/>
                     <a:p>
-                      <a:pPr lvl="0" indent="0" marL="0" algn="r">
+                      <a:pPr lvl="0" indent="0" marL="0">
                         <a:buNone/>
                       </a:pPr>
                       <a:r>
@@ -44857,7 +44878,7 @@
                     <a:bodyPr/>
                     <a:lstStyle/>
                     <a:p>
-                      <a:pPr lvl="0" indent="0" marL="0" algn="r">
+                      <a:pPr lvl="0" indent="0" marL="0">
                         <a:buNone/>
                       </a:pPr>
                       <a:r>
@@ -44920,7 +44941,7 @@
                     <a:bodyPr/>
                     <a:lstStyle/>
                     <a:p>
-                      <a:pPr lvl="0" indent="0" marL="0" algn="r">
+                      <a:pPr lvl="0" indent="0" marL="0">
                         <a:buNone/>
                       </a:pPr>
                       <a:r>
@@ -45927,7 +45948,7 @@
                       </a:pPr>
                       <a:r>
                         <a:rPr/>
-                        <a:t>điểm nghẽn lớn nhất — biển hai dòng</a:t>
+                        <a:t>Điểm nghẽn lớn nhất — biển hai dòng</a:t>
                       </a:r>
                     </a:p>
                   </a:txBody>
@@ -45974,7 +45995,7 @@
                       </a:pPr>
                       <a:r>
                         <a:rPr/>
-                        <a:t>Rẻ nhất: dữ liệu đã có sẵn</a:t>
+                        <a:t>Tối ưu hóa: dữ liệu đã có sẵn</a:t>
                       </a:r>
                     </a:p>
                   </a:txBody>
@@ -46318,7 +46339,7 @@
             </a:pPr>
             <a:r>
               <a:rPr/>
-              <a:t>Cảm ơn — và mời đặt câu hỏi</a:t>
+              <a:t>Cảm ơn</a:t>
             </a:r>
           </a:p>
         </p:txBody>
@@ -46366,7 +46387,7 @@
             </a:r>
             <a:r>
               <a:rPr/>
-              <a:t>, không bằng mô hình mạnh hơn — đóng góp </a:t>
+              <a:t>, không bằng mô hình nặng hơn — đóng góp </a:t>
             </a:r>
             <a:r>
               <a:rPr b="1"/>
@@ -46417,7 +46438,7 @@
             </a:pPr>
             <a:r>
               <a:rPr b="1"/>
-              <a:t>Xin cảm ơn thầy cô và các bạn đã lắng nghe.</a:t>
+              <a:t>Nhóm thực hiện xin trân trọng cảm ơn Quý Thầy/Cô và các bạn đã lắng nghe.</a:t>
             </a:r>
           </a:p>
         </p:txBody>
@@ -48169,7 +48190,7 @@
             </a:pPr>
             <a:r>
               <a:rPr/>
-              <a:t>Vì sao biển hai dòng làm gãy bộ nhận dạng</a:t>
+              <a:t>Vì sao biển hai dòng làm suy giảm hiệu năng OCR</a:t>
             </a:r>
           </a:p>
         </p:txBody>
@@ -49087,7 +49108,7 @@
   <p:cSld>
     <p:spTree>
       <p:nvGrpSpPr>
-        <p:cNvPr id="134" name="Shape 134"/>
+        <p:cNvPr id="428" name="Shape 428"/>
         <p:cNvGrpSpPr/>
         <p:nvPr/>
       </p:nvGrpSpPr>
@@ -49101,7 +49122,7 @@
       </p:grpSpPr>
       <p:sp>
         <p:nvSpPr>
-          <p:cNvPr id="142" name="Google Shape;142;p23"/>
+          <p:cNvPr id="436" name="Google Shape;436;p31"/>
           <p:cNvSpPr txBox="1"/>
           <p:nvPr>
             <p:ph type="title"/>
@@ -49109,8 +49130,8 @@
         </p:nvSpPr>
         <p:spPr>
           <a:xfrm>
-            <a:off x="774145" y="223964"/>
-            <a:ext cx="10579655" cy="785896"/>
+            <a:off x="771525" y="200025"/>
+            <a:ext cx="10582275" cy="790575"/>
           </a:xfrm>
           <a:prstGeom prst="rect">
             <a:avLst/>
@@ -49136,10 +49157,10 @@
       </p:sp>
       <p:sp>
         <p:nvSpPr>
-          <p:cNvPr id="143" name="Google Shape;143;p23"/>
+          <p:cNvPr id="437" name="Google Shape;437;p31"/>
           <p:cNvSpPr txBox="1"/>
           <p:nvPr>
-            <p:ph idx="1"/>
+            <p:ph idx="2" sz="half" type="body"/>
           </p:nvPr>
         </p:nvSpPr>
         <p:spPr/>
@@ -49163,20 +49184,41 @@
               <a:t>.</a:t>
             </a:r>
           </a:p>
-          <a:p>
-            <a:pPr lvl="0" indent="0" marL="0">
-              <a:buNone/>
-            </a:pPr>
-            <a:r>
-              <a:rPr/>
-              <a:t>![](figures/fig-đường ống-strip-ngang.png)</a:t>
-            </a:r>
-          </a:p>
         </p:txBody>
       </p:sp>
+      <p:pic>
+        <p:nvPicPr>
+          <p:cNvPr descr="figures/fig-pipeline-strip-ngang.png" id="0" name="Picture 1"/>
+          <p:cNvPicPr>
+            <a:picLocks noGrp="1" noChangeAspect="1"/>
+          </p:cNvPicPr>
+          <p:nvPr/>
+        </p:nvPicPr>
+        <p:blipFill>
+          <a:blip r:embed="rId2"/>
+          <a:stretch>
+            <a:fillRect/>
+          </a:stretch>
+        </p:blipFill>
+        <p:spPr bwMode="auto">
+          <a:xfrm>
+            <a:off x="3911600" y="2324100"/>
+            <a:ext cx="4292600" cy="3848100"/>
+          </a:xfrm>
+          <a:prstGeom prst="rect">
+            <a:avLst/>
+          </a:prstGeom>
+          <a:noFill/>
+          <a:ln w="9525">
+            <a:noFill/>
+            <a:headEnd/>
+            <a:tailEnd/>
+          </a:ln>
+        </p:spPr>
+      </p:pic>
       <p:sp>
         <p:nvSpPr>
-          <p:cNvPr id="155" name="Google Shape;155;p23"/>
+          <p:cNvPr id="449" name="Google Shape;449;p31"/>
           <p:cNvSpPr txBox="1"/>
           <p:nvPr>
             <p:ph idx="12" type="sldNum"/>
@@ -50121,7 +50163,7 @@
                     <a:bodyPr/>
                     <a:lstStyle/>
                     <a:p>
-                      <a:pPr lvl="0" indent="0" marL="0" algn="r">
+                      <a:pPr lvl="0" indent="0" marL="0">
                         <a:buNone/>
                       </a:pPr>
                       <a:r>
@@ -50137,7 +50179,7 @@
                     <a:bodyPr/>
                     <a:lstStyle/>
                     <a:p>
-                      <a:pPr lvl="0" indent="0" marL="0" algn="r">
+                      <a:pPr lvl="0" indent="0" marL="0">
                         <a:buNone/>
                       </a:pPr>
                       <a:r>
@@ -50180,7 +50222,7 @@
                     <a:bodyPr/>
                     <a:lstStyle/>
                     <a:p>
-                      <a:pPr lvl="0" indent="0" marL="0" algn="r">
+                      <a:pPr lvl="0" indent="0" marL="0">
                         <a:buNone/>
                       </a:pPr>
                       <a:r>
@@ -50199,7 +50241,7 @@
                     <a:bodyPr/>
                     <a:lstStyle/>
                     <a:p>
-                      <a:pPr lvl="0" indent="0" marL="0" algn="r">
+                      <a:pPr lvl="0" indent="0" marL="0">
                         <a:buNone/>
                       </a:pPr>
                       <a:r>
@@ -50246,7 +50288,7 @@
                     <a:bodyPr/>
                     <a:lstStyle/>
                     <a:p>
-                      <a:pPr lvl="0" indent="0" marL="0" algn="r">
+                      <a:pPr lvl="0" indent="0" marL="0">
                         <a:buNone/>
                       </a:pPr>
                       <a:r>
@@ -50261,7 +50303,7 @@
                     <a:bodyPr/>
                     <a:lstStyle/>
                     <a:p>
-                      <a:pPr lvl="0" indent="0" marL="0" algn="r">
+                      <a:pPr lvl="0" indent="0" marL="0">
                         <a:buNone/>
                       </a:pPr>
                       <a:r>
@@ -50308,7 +50350,7 @@
                     <a:bodyPr/>
                     <a:lstStyle/>
                     <a:p>
-                      <a:pPr lvl="0" indent="0" marL="0" algn="r">
+                      <a:pPr lvl="0" indent="0" marL="0">
                         <a:buNone/>
                       </a:pPr>
                       <a:r>
@@ -50323,7 +50365,7 @@
                     <a:bodyPr/>
                     <a:lstStyle/>
                     <a:p>
-                      <a:pPr lvl="0" indent="0" marL="0" algn="r">
+                      <a:pPr lvl="0" indent="0" marL="0">
                         <a:buNone/>
                       </a:pPr>
                       <a:r>
@@ -50370,7 +50412,7 @@
                     <a:bodyPr/>
                     <a:lstStyle/>
                     <a:p>
-                      <a:pPr lvl="0" indent="0" marL="0" algn="r">
+                      <a:pPr lvl="0" indent="0" marL="0">
                         <a:buNone/>
                       </a:pPr>
                       <a:r>
@@ -50385,7 +50427,7 @@
                     <a:bodyPr/>
                     <a:lstStyle/>
                     <a:p>
-                      <a:pPr lvl="0" indent="0" marL="0" algn="r">
+                      <a:pPr lvl="0" indent="0" marL="0">
                         <a:buNone/>
                       </a:pPr>
                       <a:r>
@@ -50436,7 +50478,7 @@
                     <a:bodyPr/>
                     <a:lstStyle/>
                     <a:p>
-                      <a:pPr lvl="0" indent="0" marL="0" algn="r">
+                      <a:pPr lvl="0" indent="0" marL="0">
                         <a:buNone/>
                       </a:pPr>
                       <a:r>
@@ -50451,7 +50493,7 @@
                     <a:bodyPr/>
                     <a:lstStyle/>
                     <a:p>
-                      <a:pPr lvl="0" indent="0" marL="0" algn="r">
+                      <a:pPr lvl="0" indent="0" marL="0">
                         <a:buNone/>
                       </a:pPr>
                       <a:r>
@@ -50502,7 +50544,7 @@
                     <a:bodyPr/>
                     <a:lstStyle/>
                     <a:p>
-                      <a:pPr lvl="0" indent="0" marL="0" algn="r">
+                      <a:pPr lvl="0" indent="0" marL="0">
                         <a:buNone/>
                       </a:pPr>
                       <a:r>
@@ -50517,7 +50559,7 @@
                     <a:bodyPr/>
                     <a:lstStyle/>
                     <a:p>
-                      <a:pPr lvl="0" indent="0" marL="0" algn="r">
+                      <a:pPr lvl="0" indent="0" marL="0">
                         <a:buNone/>
                       </a:pPr>
                       <a:r>
@@ -50564,7 +50606,7 @@
                     <a:bodyPr/>
                     <a:lstStyle/>
                     <a:p>
-                      <a:pPr lvl="0" indent="0" marL="0" algn="r">
+                      <a:pPr lvl="0" indent="0" marL="0">
                         <a:buNone/>
                       </a:pPr>
                       <a:r>
@@ -50583,7 +50625,7 @@
                     <a:bodyPr/>
                     <a:lstStyle/>
                     <a:p>
-                      <a:pPr lvl="0" indent="0" marL="0" algn="r">
+                      <a:pPr lvl="0" indent="0" marL="0">
                         <a:buNone/>
                       </a:pPr>
                       <a:r>

</xml_diff>

<commit_message>
fix(mon-hoc): dien GV va du 4 sinh vien nhom mon hoc len bia + slide + README
Trang bia con nguyen cho giu «dien ten giang vien phu trach mon» — theo
thong tin nguoi thuc hien cung cap: GV ThS. Cap Pham Dinh Thang, va nhom
mon hoc gom BON sinh vien (khac nhom DATN 2 nguoi):
  25410004 Pham Nguyen The Chau · 25410006 Nguyen Cong Hau
  25410007 Nguyen Minh Hieu     · 25410013 Pham Cong Thanh

Sua o ba noi: bia quyen (01-front-matter), dong tac gia slide bia (tach
2 dong cho khoi tran), va README nhanh. Dung + xuat lai: PDF 40 trang,
bia du 4 MSSV + GV, 0 placeholder; check_slides 16 slide 0 loi.
</commit_message>
<xml_diff>
--- a/docs/slides/12-slides-mon-hoc.pptx
+++ b/docs/slides/12-slides-mon-hoc.pptx
@@ -43733,7 +43733,12 @@
             <a:br/>
             <a:r>
               <a:rPr/>
-              <a:t>Phạm Công Thành — 25410013 · Nguyễn Minh Hiếu — 25410007</a:t>
+              <a:t>Phạm Nguyễn Thế Châu — 25410004 · Nguyễn Công Hậu — 25410006</a:t>
+            </a:r>
+            <a:br/>
+            <a:r>
+              <a:rPr/>
+              <a:t>Nguyễn Minh Hiếu — 25410007 · Phạm Công Thành — 25410013</a:t>
             </a:r>
           </a:p>
         </p:txBody>

</xml_diff>

<commit_message>
docs(mon-hoc): dong bo slide 13/15 voi quyen; bo han che 5 da khep khoi Bang 5.2
1. Slide 15 huong #2 "Thay bang anh xa bang bang trich tu ma tran" doc nhu
   chua lam, trong khi 4.3.3 noi da thay mot phan. Doi thanh "Mo rong bang
   anh xa tu ma tran nham lan khi co them du lieu" + ghi chu vong dau da
   +53 bien, 5 cap con lai chua du bang chung — khop Bang 5.3 hang 2.
2. Bang 5.2: bo hang 5 (do tre p95 — da khep; "da khep sao con trong bang
   han che?"). Sau -> Nam han che, hang 6 -> 5; Bang 5.3 cot "Giai han che"
   2,6 -> 2,5 va huong 6 (tang toc) -> "—".
3. Slide 13 "mot trong hai suy sai chieu" mau thuan Bang 4.6 (ca hai cap
   duoc phu deu dung chieu). Kiem ma nguon plate_rules.py: TO_LETTER 1->L
   dung, TO_DIGIT L->4 (ban do, khong phai L->1). Cai sai la muc L->1 o vi
   tri chu so doan sai DICH; sua cau cho dung: "muc L->1 o vi tri chu so
   doan sai dich — do duoc L that ra la 4 (53 lan)".

Kiem: refs 0 chet, PDF 40 trang, PAGEREF nguyen, check_slides 16/0 loi.
</commit_message>
<xml_diff>
--- a/docs/slides/12-slides-mon-hoc.pptx
+++ b/docs/slides/12-slides-mon-hoc.pptx
@@ -44944,15 +44944,45 @@
             </a:r>
             <a:r>
               <a:rPr/>
-              <a:t> — và một trong hai suy </a:t>
+              <a:t>, và mục </a:t>
+            </a:r>
+            <a:r>
+              <a:rPr>
+                <a:latin typeface="Courier"/>
+              </a:rPr>
+              <a:t>L → 1</a:t>
+            </a:r>
+            <a:r>
+              <a:rPr/>
+              <a:t> ở vị trí chữ số đoán </a:t>
             </a:r>
             <a:r>
               <a:rPr b="1"/>
-              <a:t>sai chiều</a:t>
+              <a:t>sai đích</a:t>
             </a:r>
             <a:r>
               <a:rPr/>
-              <a:t>. Thay bằng bảng trích từ ma trận đo được: phủ </a:t>
+              <a:t> — đo được </a:t>
+            </a:r>
+            <a:r>
+              <a:rPr>
+                <a:latin typeface="Courier"/>
+              </a:rPr>
+              <a:t>L</a:t>
+            </a:r>
+            <a:r>
+              <a:rPr/>
+              <a:t> thật ra là </a:t>
+            </a:r>
+            <a:r>
+              <a:rPr>
+                <a:latin typeface="Courier"/>
+              </a:rPr>
+              <a:t>4</a:t>
+            </a:r>
+            <a:r>
+              <a:rPr/>
+              <a:t> (53 lần). Bảng trích từ ma trận đo được: phủ </a:t>
             </a:r>
             <a:r>
               <a:rPr b="1"/>
@@ -45677,7 +45707,7 @@
                       </a:pPr>
                       <a:r>
                         <a:rPr b="1"/>
-                        <a:t>Thay bảng ánh xạ bằng bảng trích từ ma trận đo được</a:t>
+                        <a:t>Mở rộng bảng ánh xạ từ ma trận nhầm lẫn khi có thêm dữ liệu</a:t>
                       </a:r>
                     </a:p>
                   </a:txBody>
@@ -45692,7 +45722,7 @@
                       </a:pPr>
                       <a:r>
                         <a:rPr/>
-                        <a:t>Tối ưu hóa: dữ liệu đã có sẵn</a:t>
+                        <a:t>Vòng đầu đã +53 biển; 5 cặp còn lại chưa đủ bằng chứng</a:t>
                       </a:r>
                     </a:p>
                   </a:txBody>

</xml_diff>

<commit_message>
docs(slide mon hoc): slide 13 bo tranh luan L->1, slide cuoi doi giong ket
Slide 13: cau "L->1 doan sai dich" de bi doi chieu voi Bang 4.6 (hang 1
L->1, 90 lan, "co — dung chieu"). Rut ve dung hai con so quyen cong bo:
bang hinh dang phu 2/10, bang ma tran phu 4/10 va +53 bien.
Slide cuoi: "Chua dat 0,7701 so voi nguong 0,85" -> "Diem nghen con lai:
bien hai dong (S1 = 0,7234)" — cung su that, dung cach dat van de cua
chuong 4.

Kiem: check_slides 16/0 loi; quyen khong doi (40 trang, xuat lai de giu
PAGEREF trong docx).
</commit_message>
<xml_diff>
--- a/docs/slides/12-slides-mon-hoc.pptx
+++ b/docs/slides/12-slides-mon-hoc.pptx
@@ -44940,49 +44940,11 @@
             <a:pPr lvl="0"/>
             <a:r>
               <a:rPr b="1"/>
-              <a:t>Bảng ánh xạ suy từ hình dạng chỉ phủ 2/10 cặp</a:t>
+              <a:t>Bảng luật suy từ hình dạng chỉ phủ 2/10 cặp nhầm phổ biến nhất</a:t>
             </a:r>
             <a:r>
               <a:rPr/>
-              <a:t>, và mục </a:t>
-            </a:r>
-            <a:r>
-              <a:rPr>
-                <a:latin typeface="Courier"/>
-              </a:rPr>
-              <a:t>L → 1</a:t>
-            </a:r>
-            <a:r>
-              <a:rPr/>
-              <a:t> ở vị trí chữ số đoán </a:t>
-            </a:r>
-            <a:r>
-              <a:rPr b="1"/>
-              <a:t>sai đích</a:t>
-            </a:r>
-            <a:r>
-              <a:rPr/>
-              <a:t> — đo được </a:t>
-            </a:r>
-            <a:r>
-              <a:rPr>
-                <a:latin typeface="Courier"/>
-              </a:rPr>
-              <a:t>L</a:t>
-            </a:r>
-            <a:r>
-              <a:rPr/>
-              <a:t> thật ra là </a:t>
-            </a:r>
-            <a:r>
-              <a:rPr>
-                <a:latin typeface="Courier"/>
-              </a:rPr>
-              <a:t>4</a:t>
-            </a:r>
-            <a:r>
-              <a:rPr/>
-              <a:t> (53 lần). Bảng trích từ ma trận đo được: phủ </a:t>
+              <a:t>; bảng trích từ ma trận đo được phủ </a:t>
             </a:r>
             <a:r>
               <a:rPr b="1"/>
@@ -44990,11 +44952,11 @@
             </a:r>
             <a:r>
               <a:rPr/>
-              <a:t>, thêm </a:t>
+              <a:t> và thêm </a:t>
             </a:r>
             <a:r>
               <a:rPr b="1"/>
-              <a:t>53 biển đúng, 0 hỏng</a:t>
+              <a:t>53 biển đúng</a:t>
             </a:r>
           </a:p>
           <a:p>
@@ -46140,15 +46102,15 @@
             <a:pPr lvl="0"/>
             <a:r>
               <a:rPr/>
-              <a:t>Chưa đạt: đọc đúng cả chuỗi </a:t>
+              <a:t>Điểm nghẽn còn lại: </a:t>
             </a:r>
             <a:r>
               <a:rPr b="1"/>
-              <a:t>0,7701</a:t>
+              <a:t>biển hai dòng</a:t>
             </a:r>
             <a:r>
               <a:rPr/>
-              <a:t> so với ngưỡng 0,85</a:t>
+              <a:t> (S₁ = 0,7234)</a:t>
             </a:r>
           </a:p>
           <a:p>

</xml_diff>